<commit_message>
update Thu 07/30/2026 16:25:53.77
</commit_message>
<xml_diff>
--- a/executive_presentation.pptx
+++ b/executive_presentation.pptx
@@ -1782,200 +1782,9 @@
           </a:bodyPr>
           <a:lstStyle/>
           <a:p>
-            <a:pPr indent="0" lvl="0" marL="0" rtl="0" algn="l">
-              <a:lnSpc>
-                <a:spcPct val="100000"/>
-              </a:lnSpc>
-              <a:spcBef>
-                <a:spcPts val="0"/>
-              </a:spcBef>
-              <a:spcAft>
-                <a:spcPts val="0"/>
-              </a:spcAft>
-              <a:buSzPts val="1400"/>
-              <a:buNone/>
-            </a:pPr>
-            <a:r>
-              <a:t/>
-            </a:r>
-            <a:endParaRPr/>
-          </a:p>
-          <a:p>
-            <a:pPr indent="0" lvl="0" marL="0" rtl="0" algn="l">
-              <a:lnSpc>
-                <a:spcPct val="100000"/>
-              </a:lnSpc>
-              <a:spcBef>
-                <a:spcPts val="0"/>
-              </a:spcBef>
-              <a:spcAft>
-                <a:spcPts val="0"/>
-              </a:spcAft>
-              <a:buSzPts val="1400"/>
-              <a:buNone/>
-            </a:pPr>
-            <a:r>
-              <a:rPr lang="en-US"/>
-              <a:t>CLAUDE: </a:t>
-            </a:r>
-            <a:endParaRPr/>
-          </a:p>
-          <a:p>
-            <a:pPr indent="0" lvl="0" marL="0" rtl="0" algn="l">
-              <a:lnSpc>
-                <a:spcPct val="100000"/>
-              </a:lnSpc>
-              <a:spcBef>
-                <a:spcPts val="0"/>
-              </a:spcBef>
-              <a:spcAft>
-                <a:spcPts val="0"/>
-              </a:spcAft>
-              <a:buSzPts val="1400"/>
-              <a:buNone/>
-            </a:pPr>
-            <a:r>
-              <a:rPr lang="en-US"/>
-              <a:t>Write me a script to explain everything I did in order </a:t>
-            </a:r>
-            <a:endParaRPr/>
-          </a:p>
-          <a:p>
-            <a:pPr indent="0" lvl="0" marL="0" rtl="0" algn="l">
-              <a:lnSpc>
-                <a:spcPct val="100000"/>
-              </a:lnSpc>
-              <a:spcBef>
-                <a:spcPts val="0"/>
-              </a:spcBef>
-              <a:spcAft>
-                <a:spcPts val="0"/>
-              </a:spcAft>
-              <a:buSzPts val="1400"/>
-              <a:buNone/>
-            </a:pPr>
-            <a:r>
-              <a:rPr lang="en-US"/>
-              <a:t>Tell me how I can test the data - like should I run any sql queries in bq to validate some things? </a:t>
-            </a:r>
-            <a:endParaRPr/>
-          </a:p>
-          <a:p>
-            <a:pPr indent="0" lvl="0" marL="0" rtl="0" algn="l">
-              <a:lnSpc>
-                <a:spcPct val="100000"/>
-              </a:lnSpc>
-              <a:spcBef>
-                <a:spcPts val="0"/>
-              </a:spcBef>
-              <a:spcAft>
-                <a:spcPts val="0"/>
-              </a:spcAft>
-              <a:buSzPts val="1400"/>
-              <a:buNone/>
-            </a:pPr>
-            <a:r>
-              <a:rPr lang="en-US"/>
-              <a:t>If you didn’t have AI, how would you test that everything is correct? </a:t>
-            </a:r>
-            <a:endParaRPr/>
-          </a:p>
-          <a:p>
-            <a:pPr indent="0" lvl="0" marL="0" rtl="0" algn="l">
-              <a:lnSpc>
-                <a:spcPct val="100000"/>
-              </a:lnSpc>
-              <a:spcBef>
-                <a:spcPts val="0"/>
-              </a:spcBef>
-              <a:spcAft>
-                <a:spcPts val="0"/>
-              </a:spcAft>
-              <a:buSzPts val="1400"/>
-              <a:buNone/>
-            </a:pPr>
-            <a:r>
-              <a:rPr lang="en-US"/>
-              <a:t>What are some lessons learned or things I had to correct with AI generated work? I caught over complicated metrics… simplified for ease of understanding</a:t>
-            </a:r>
-            <a:endParaRPr/>
-          </a:p>
-          <a:p>
-            <a:pPr indent="0" lvl="0" marL="0" rtl="0" algn="l">
-              <a:lnSpc>
-                <a:spcPct val="100000"/>
-              </a:lnSpc>
-              <a:spcBef>
-                <a:spcPts val="0"/>
-              </a:spcBef>
-              <a:spcAft>
-                <a:spcPts val="0"/>
-              </a:spcAft>
-              <a:buSzPts val="1400"/>
-              <a:buNone/>
-            </a:pPr>
-            <a:r>
-              <a:t/>
-            </a:r>
-            <a:endParaRPr/>
-          </a:p>
-          <a:p>
-            <a:pPr indent="0" lvl="0" marL="0" rtl="0" algn="l">
-              <a:lnSpc>
-                <a:spcPct val="100000"/>
-              </a:lnSpc>
-              <a:spcBef>
-                <a:spcPts val="0"/>
-              </a:spcBef>
-              <a:spcAft>
-                <a:spcPts val="0"/>
-              </a:spcAft>
-              <a:buSzPts val="1400"/>
-              <a:buNone/>
-            </a:pPr>
-            <a:r>
-              <a:t/>
-            </a:r>
-            <a:endParaRPr/>
-          </a:p>
-          <a:p>
-            <a:pPr indent="0" lvl="0" marL="0" rtl="0" algn="l">
-              <a:lnSpc>
-                <a:spcPct val="100000"/>
-              </a:lnSpc>
-              <a:spcBef>
-                <a:spcPts val="0"/>
-              </a:spcBef>
-              <a:spcAft>
-                <a:spcPts val="0"/>
-              </a:spcAft>
-              <a:buSzPts val="1400"/>
-              <a:buNone/>
-            </a:pPr>
-            <a:r>
-              <a:t/>
-            </a:r>
-            <a:endParaRPr/>
-          </a:p>
-          <a:p>
-            <a:pPr indent="0" lvl="0" marL="0" rtl="0" algn="l">
-              <a:lnSpc>
-                <a:spcPct val="100000"/>
-              </a:lnSpc>
-              <a:spcBef>
-                <a:spcPts val="0"/>
-              </a:spcBef>
-              <a:spcAft>
-                <a:spcPts val="0"/>
-              </a:spcAft>
-              <a:buSzPts val="1400"/>
-              <a:buNone/>
-            </a:pPr>
-            <a:r>
-              <a:rPr lang="en-US"/>
+            <a:r>
               <a:t>SECTION - INTRODUCTION. Open with your background (~2 min), then land the Technical PM philosophy verbally: (1) Metrics are incentive design - the question is never what can we measure, it is what behavior do we want to pay for; a metric that can be gamed will be gamed. (2) Own the pipeline, not just the deck - I wrote the specs, the SQL, and the tests behind every number shown today; spec-driven, AI-accelerated from Markdown contract to working prototype in days. (3) Evidence over narrative - every figure is recomputed from raw data and enforced by automated tests; if a number cannot be reproduced, it does not ship. Arc for today: the problem with how we measure -&gt; the metric -&gt; how it is built -&gt; does it actually catch things -&gt; what it changes -&gt; decisions and discussion.</a:t>
             </a:r>
-            <a:endParaRPr/>
           </a:p>
         </p:txBody>
       </p:sp>
@@ -3076,7 +2885,7 @@
           <a:lstStyle/>
           <a:p>
             <a:r>
-              <a:t>APPENDIX - reference only, do not present unless asked. Exact per-signal math and thresholds. If probed on the feature-volume benchmarks: each feature is judged against its own expected monthly volume, so heavy and light features are comparable. If probed on the 10% meaningful-use floor for TTV: deployment is not a distinct event in consumption data; the floor keeps a single test ping from counting as deployed. Grace period: TTV is null (excluded from weighting) for the first 30 days of a contract, so brand-new accounts are not penalized.</a:t>
+              <a:t>APPENDIX - reference only, do not present unless asked. Exact per-signal math, thresholds, and both guardrail flags. If probed on feature benchmarks: each feature is judged against its own expected monthly volume, so heavy and light features are comparable. If probed on the 10% meaningful-use floor for TTV: deployment is not a distinct event in consumption data; the floor keeps a single test ping from counting as deployed. Grace period: TTV is null (excluded from weighting) for the first 30 days, so brand-new accounts are not penalized. Single-feature rule uses RAW utilization ≥ 0.9, not the capped health score, so overage accounts are not exempt.</a:t>
             </a:r>
           </a:p>
         </p:txBody>
@@ -5945,71 +5754,6 @@
           <a:chExt cx="0" cy="0"/>
         </a:xfrm>
       </p:grpSpPr>
-      <p:sp>
-        <p:nvSpPr>
-          <p:cNvPr id="57" name="Google Shape;57;p3"/>
-          <p:cNvSpPr/>
-          <p:nvPr/>
-        </p:nvSpPr>
-        <p:spPr>
-          <a:xfrm>
-            <a:off x="445493" y="4955436"/>
-            <a:ext cx="10896600" cy="741900"/>
-          </a:xfrm>
-          <a:prstGeom prst="rect">
-            <a:avLst/>
-          </a:prstGeom>
-          <a:solidFill>
-            <a:srgbClr val="F7F7F7"/>
-          </a:solidFill>
-          <a:ln cap="flat" cmpd="sng" w="12700">
-            <a:solidFill>
-              <a:srgbClr val="E5E5E5"/>
-            </a:solidFill>
-            <a:prstDash val="solid"/>
-            <a:round/>
-            <a:headEnd len="sm" w="sm" type="none"/>
-            <a:tailEnd len="sm" w="sm" type="none"/>
-          </a:ln>
-        </p:spPr>
-        <p:txBody>
-          <a:bodyPr anchorCtr="0" anchor="ctr" bIns="91425" lIns="91425" spcFirstLastPara="1" rIns="91425" wrap="square" tIns="91425">
-            <a:noAutofit/>
-          </a:bodyPr>
-          <a:lstStyle/>
-          <a:p>
-            <a:pPr indent="0" lvl="0" marL="0" marR="0" rtl="0" algn="l">
-              <a:lnSpc>
-                <a:spcPct val="100000"/>
-              </a:lnSpc>
-              <a:spcBef>
-                <a:spcPts val="0"/>
-              </a:spcBef>
-              <a:spcAft>
-                <a:spcPts val="0"/>
-              </a:spcAft>
-              <a:buClr>
-                <a:srgbClr val="000000"/>
-              </a:buClr>
-              <a:buSzPts val="1400"/>
-              <a:buFont typeface="Arial"/>
-              <a:buNone/>
-            </a:pPr>
-            <a:r>
-              <a:t/>
-            </a:r>
-            <a:endParaRPr i="0" sz="1400" u="none" cap="none" strike="noStrike">
-              <a:solidFill>
-                <a:srgbClr val="000000"/>
-              </a:solidFill>
-              <a:latin typeface="Helvetica Neue"/>
-              <a:ea typeface="Helvetica Neue"/>
-              <a:cs typeface="Helvetica Neue"/>
-              <a:sym typeface="Helvetica Neue"/>
-            </a:endParaRPr>
-          </a:p>
-        </p:txBody>
-      </p:sp>
       <p:pic>
         <p:nvPicPr>
           <p:cNvPr descr="preencoded.png" id="58" name="Google Shape;58;p3"/>
@@ -7427,104 +7171,14 @@
       </p:sp>
       <p:sp>
         <p:nvSpPr>
-          <p:cNvPr id="76" name="Google Shape;76;p3"/>
-          <p:cNvSpPr/>
-          <p:nvPr/>
-        </p:nvSpPr>
-        <p:spPr>
-          <a:xfrm>
-            <a:off x="548640" y="5120640"/>
-            <a:ext cx="11064300" cy="411600"/>
-          </a:xfrm>
-          <a:prstGeom prst="rect">
-            <a:avLst/>
-          </a:prstGeom>
-          <a:noFill/>
-          <a:ln>
-            <a:noFill/>
-          </a:ln>
-        </p:spPr>
-        <p:txBody>
-          <a:bodyPr anchorCtr="0" anchor="ctr" bIns="0" lIns="0" spcFirstLastPara="1" rIns="0" wrap="square" tIns="0">
-            <a:noAutofit/>
-          </a:bodyPr>
-          <a:lstStyle/>
-          <a:p>
-            <a:pPr indent="0" lvl="0" marL="0" marR="0" rtl="0" algn="l">
-              <a:lnSpc>
-                <a:spcPct val="100000"/>
-              </a:lnSpc>
-              <a:spcBef>
-                <a:spcPts val="0"/>
-              </a:spcBef>
-              <a:spcAft>
-                <a:spcPts val="0"/>
-              </a:spcAft>
-              <a:buClr>
-                <a:srgbClr val="C84624"/>
-              </a:buClr>
-              <a:buSzPts val="1250"/>
-              <a:buFont typeface="Helvetica Neue"/>
-              <a:buNone/>
-            </a:pPr>
-            <a:r>
-              <a:rPr b="1" lang="en-US" sz="1350">
-                <a:solidFill>
-                  <a:srgbClr val="C84624"/>
-                </a:solidFill>
-                <a:latin typeface="Helvetica Neue"/>
-                <a:ea typeface="Helvetica Neue"/>
-                <a:cs typeface="Helvetica Neue"/>
-                <a:sym typeface="Helvetica Neue"/>
-              </a:rPr>
-              <a:t>Weighted by ARR</a:t>
-            </a:r>
-            <a:r>
-              <a:rPr i="0" lang="en-US" sz="1350" u="none" cap="none" strike="noStrike">
-                <a:solidFill>
-                  <a:srgbClr val="575757"/>
-                </a:solidFill>
-                <a:latin typeface="Helvetica Neue"/>
-                <a:ea typeface="Helvetica Neue"/>
-                <a:cs typeface="Helvetica Neue"/>
-                <a:sym typeface="Helvetica Neue"/>
-              </a:rPr>
-              <a:t>— S</a:t>
-            </a:r>
-            <a:r>
-              <a:rPr lang="en-US" sz="1350">
-                <a:solidFill>
-                  <a:srgbClr val="575757"/>
-                </a:solidFill>
-                <a:latin typeface="Helvetica Neue"/>
-                <a:ea typeface="Helvetica Neue"/>
-                <a:cs typeface="Helvetica Neue"/>
-                <a:sym typeface="Helvetica Neue"/>
-              </a:rPr>
-              <a:t>core is weighted by the ARR of each product purchased, rolled up to customer, platform, and portfolio score </a:t>
-            </a:r>
-            <a:endParaRPr i="0" sz="1350" u="none" cap="none" strike="noStrike">
-              <a:solidFill>
-                <a:schemeClr val="dk1"/>
-              </a:solidFill>
-              <a:latin typeface="Helvetica Neue"/>
-              <a:ea typeface="Helvetica Neue"/>
-              <a:cs typeface="Helvetica Neue"/>
-              <a:sym typeface="Helvetica Neue"/>
-            </a:endParaRPr>
-          </a:p>
-        </p:txBody>
-      </p:sp>
-      <p:sp>
-        <p:nvSpPr>
-          <p:cNvPr id="77" name="TextBox 76"/>
+          <p:cNvPr id="76" name="TextBox 75"/>
           <p:cNvSpPr txBox="1"/>
           <p:nvPr/>
         </p:nvSpPr>
         <p:spPr>
           <a:xfrm>
-            <a:off x="548640" y="6053328"/>
-            <a:ext cx="960120" cy="274320"/>
+            <a:off x="658368" y="4864608"/>
+            <a:ext cx="2743200" cy="256032"/>
           </a:xfrm>
           <a:prstGeom prst="rect">
             <a:avLst/>
@@ -7532,34 +7186,34 @@
           <a:noFill/>
         </p:spPr>
         <p:txBody>
-          <a:bodyPr wrap="none" lIns="0" rIns="0" tIns="0" bIns="0">
+          <a:bodyPr wrap="square" lIns="0" rIns="0" tIns="0" bIns="0">
             <a:spAutoFit/>
           </a:bodyPr>
           <a:lstStyle/>
           <a:p>
             <a:pPr algn="l"/>
             <a:r>
-              <a:rPr sz="1000" b="1">
+              <a:rPr sz="1000" b="1" i="0">
                 <a:solidFill>
                   <a:srgbClr val="706B69"/>
                 </a:solidFill>
                 <a:latin typeface="Arial"/>
               </a:rPr>
-              <a:t>VRS BANDS</a:t>
+              <a:t>VRS BANDS — HOW SCORES READ</a:t>
             </a:r>
           </a:p>
         </p:txBody>
       </p:sp>
       <p:sp>
         <p:nvSpPr>
-          <p:cNvPr id="78" name="Rounded Rectangle 77"/>
+          <p:cNvPr id="77" name="Rounded Rectangle 76"/>
           <p:cNvSpPr/>
           <p:nvPr/>
         </p:nvSpPr>
         <p:spPr>
           <a:xfrm>
-            <a:off x="1600200" y="5961888"/>
-            <a:ext cx="2377440" cy="402336"/>
+            <a:off x="658368" y="5157216"/>
+            <a:ext cx="2606040" cy="420624"/>
           </a:xfrm>
           <a:prstGeom prst="roundRect">
             <a:avLst>
@@ -7607,14 +7261,49 @@
       </p:sp>
       <p:sp>
         <p:nvSpPr>
+          <p:cNvPr id="78" name="TextBox 77"/>
+          <p:cNvSpPr txBox="1"/>
+          <p:nvPr/>
+        </p:nvSpPr>
+        <p:spPr>
+          <a:xfrm>
+            <a:off x="658368" y="5669280"/>
+            <a:ext cx="2606040" cy="274320"/>
+          </a:xfrm>
+          <a:prstGeom prst="rect">
+            <a:avLst/>
+          </a:prstGeom>
+          <a:noFill/>
+        </p:spPr>
+        <p:txBody>
+          <a:bodyPr wrap="square" lIns="0" rIns="0" tIns="0" bIns="0">
+            <a:spAutoFit/>
+          </a:bodyPr>
+          <a:lstStyle/>
+          <a:p>
+            <a:pPr algn="ctr"/>
+            <a:r>
+              <a:rPr sz="1000" b="0" i="0">
+                <a:solidFill>
+                  <a:srgbClr val="706B69"/>
+                </a:solidFill>
+                <a:latin typeface="Arial"/>
+              </a:rPr>
+              <a:t>Strong value realization</a:t>
+            </a:r>
+          </a:p>
+        </p:txBody>
+      </p:sp>
+      <p:sp>
+        <p:nvSpPr>
           <p:cNvPr id="79" name="Rounded Rectangle 78"/>
           <p:cNvSpPr/>
           <p:nvPr/>
         </p:nvSpPr>
         <p:spPr>
           <a:xfrm>
-            <a:off x="4105656" y="5961888"/>
-            <a:ext cx="2377440" cy="402336"/>
+            <a:off x="3429000" y="5157216"/>
+            <a:ext cx="2606040" cy="420624"/>
           </a:xfrm>
           <a:prstGeom prst="roundRect">
             <a:avLst>
@@ -7662,14 +7351,49 @@
       </p:sp>
       <p:sp>
         <p:nvSpPr>
-          <p:cNvPr id="80" name="Rounded Rectangle 79"/>
+          <p:cNvPr id="80" name="TextBox 79"/>
+          <p:cNvSpPr txBox="1"/>
+          <p:nvPr/>
+        </p:nvSpPr>
+        <p:spPr>
+          <a:xfrm>
+            <a:off x="3429000" y="5669280"/>
+            <a:ext cx="2606040" cy="274320"/>
+          </a:xfrm>
+          <a:prstGeom prst="rect">
+            <a:avLst/>
+          </a:prstGeom>
+          <a:noFill/>
+        </p:spPr>
+        <p:txBody>
+          <a:bodyPr wrap="square" lIns="0" rIns="0" tIns="0" bIns="0">
+            <a:spAutoFit/>
+          </a:bodyPr>
+          <a:lstStyle/>
+          <a:p>
+            <a:pPr algn="ctr"/>
+            <a:r>
+              <a:rPr sz="1000" b="0" i="0">
+                <a:solidFill>
+                  <a:srgbClr val="706B69"/>
+                </a:solidFill>
+                <a:latin typeface="Arial"/>
+              </a:rPr>
+              <a:t>Partial value — quality signals lag</a:t>
+            </a:r>
+          </a:p>
+        </p:txBody>
+      </p:sp>
+      <p:sp>
+        <p:nvSpPr>
+          <p:cNvPr id="81" name="Rounded Rectangle 80"/>
           <p:cNvSpPr/>
           <p:nvPr/>
         </p:nvSpPr>
         <p:spPr>
           <a:xfrm>
-            <a:off x="6611112" y="5961888"/>
-            <a:ext cx="2377440" cy="402336"/>
+            <a:off x="6199632" y="5157216"/>
+            <a:ext cx="2606040" cy="420624"/>
           </a:xfrm>
           <a:prstGeom prst="roundRect">
             <a:avLst>
@@ -7717,14 +7441,49 @@
       </p:sp>
       <p:sp>
         <p:nvSpPr>
-          <p:cNvPr id="81" name="Rounded Rectangle 80"/>
+          <p:cNvPr id="82" name="TextBox 81"/>
+          <p:cNvSpPr txBox="1"/>
+          <p:nvPr/>
+        </p:nvSpPr>
+        <p:spPr>
+          <a:xfrm>
+            <a:off x="6199632" y="5669280"/>
+            <a:ext cx="2606040" cy="274320"/>
+          </a:xfrm>
+          <a:prstGeom prst="rect">
+            <a:avLst/>
+          </a:prstGeom>
+          <a:noFill/>
+        </p:spPr>
+        <p:txBody>
+          <a:bodyPr wrap="square" lIns="0" rIns="0" tIns="0" bIns="0">
+            <a:spAutoFit/>
+          </a:bodyPr>
+          <a:lstStyle/>
+          <a:p>
+            <a:pPr algn="ctr"/>
+            <a:r>
+              <a:rPr sz="1000" b="0" i="0">
+                <a:solidFill>
+                  <a:srgbClr val="706B69"/>
+                </a:solidFill>
+                <a:latin typeface="Arial"/>
+              </a:rPr>
+              <a:t>Largely unrealized</a:t>
+            </a:r>
+          </a:p>
+        </p:txBody>
+      </p:sp>
+      <p:sp>
+        <p:nvSpPr>
+          <p:cNvPr id="83" name="Rounded Rectangle 82"/>
           <p:cNvSpPr/>
           <p:nvPr/>
         </p:nvSpPr>
         <p:spPr>
           <a:xfrm>
-            <a:off x="9116568" y="5961888"/>
-            <a:ext cx="2377440" cy="402336"/>
+            <a:off x="8970264" y="5157216"/>
+            <a:ext cx="2606040" cy="420624"/>
           </a:xfrm>
           <a:prstGeom prst="roundRect">
             <a:avLst>
@@ -7766,6 +7525,76 @@
                 <a:latin typeface="Arial"/>
               </a:rPr>
               <a:t>Critical · 0–29</a:t>
+            </a:r>
+          </a:p>
+        </p:txBody>
+      </p:sp>
+      <p:sp>
+        <p:nvSpPr>
+          <p:cNvPr id="84" name="TextBox 83"/>
+          <p:cNvSpPr txBox="1"/>
+          <p:nvPr/>
+        </p:nvSpPr>
+        <p:spPr>
+          <a:xfrm>
+            <a:off x="8970264" y="5669280"/>
+            <a:ext cx="2606040" cy="274320"/>
+          </a:xfrm>
+          <a:prstGeom prst="rect">
+            <a:avLst/>
+          </a:prstGeom>
+          <a:noFill/>
+        </p:spPr>
+        <p:txBody>
+          <a:bodyPr wrap="square" lIns="0" rIns="0" tIns="0" bIns="0">
+            <a:spAutoFit/>
+          </a:bodyPr>
+          <a:lstStyle/>
+          <a:p>
+            <a:pPr algn="ctr"/>
+            <a:r>
+              <a:rPr sz="1000" b="0" i="0">
+                <a:solidFill>
+                  <a:srgbClr val="706B69"/>
+                </a:solidFill>
+                <a:latin typeface="Arial"/>
+              </a:rPr>
+              <a:t>Near-dormant — shelfware or lapsed</a:t>
+            </a:r>
+          </a:p>
+        </p:txBody>
+      </p:sp>
+      <p:sp>
+        <p:nvSpPr>
+          <p:cNvPr id="85" name="TextBox 84"/>
+          <p:cNvSpPr txBox="1"/>
+          <p:nvPr/>
+        </p:nvSpPr>
+        <p:spPr>
+          <a:xfrm>
+            <a:off x="658368" y="6108192"/>
+            <a:ext cx="10917936" cy="274320"/>
+          </a:xfrm>
+          <a:prstGeom prst="rect">
+            <a:avLst/>
+          </a:prstGeom>
+          <a:noFill/>
+        </p:spPr>
+        <p:txBody>
+          <a:bodyPr wrap="square" lIns="0" rIns="0" tIns="0" bIns="0">
+            <a:spAutoFit/>
+          </a:bodyPr>
+          <a:lstStyle/>
+          <a:p>
+            <a:pPr algn="ctr"/>
+            <a:r>
+              <a:rPr sz="1100" b="0" i="1">
+                <a:solidFill>
+                  <a:srgbClr val="706B69"/>
+                </a:solidFill>
+                <a:latin typeface="Arial"/>
+              </a:rPr>
+              <a:t>Weighted by ARR — each product's score is weighted by its ARR, rolled up to customer, platform, and portfolio</a:t>
             </a:r>
           </a:p>
         </p:txBody>
@@ -9088,7 +8917,7 @@
                     <a:cs typeface="Helvetica Neue"/>
                     <a:sym typeface="Helvetica Neue"/>
                   </a:rPr>
-                  <a:t>21 automated checks enforce quality and verify recovery rates</a:t>
+                  <a:t>36 automated checks enforce quality and verify recovery rates</a:t>
                 </a:r>
                 <a:endParaRPr b="0" sz="1150">
                   <a:solidFill>
@@ -14790,71 +14619,6 @@
           <a:chExt cx="0" cy="0"/>
         </a:xfrm>
       </p:grpSpPr>
-      <p:sp>
-        <p:nvSpPr>
-          <p:cNvPr id="57" name="Google Shape;57;p3"/>
-          <p:cNvSpPr/>
-          <p:nvPr/>
-        </p:nvSpPr>
-        <p:spPr>
-          <a:xfrm>
-            <a:off x="445493" y="4955436"/>
-            <a:ext cx="10896600" cy="741900"/>
-          </a:xfrm>
-          <a:prstGeom prst="rect">
-            <a:avLst/>
-          </a:prstGeom>
-          <a:solidFill>
-            <a:srgbClr val="F7F7F7"/>
-          </a:solidFill>
-          <a:ln cap="flat" cmpd="sng" w="12700">
-            <a:solidFill>
-              <a:srgbClr val="E5E5E5"/>
-            </a:solidFill>
-            <a:prstDash val="solid"/>
-            <a:round/>
-            <a:headEnd len="sm" w="sm" type="none"/>
-            <a:tailEnd len="sm" w="sm" type="none"/>
-          </a:ln>
-        </p:spPr>
-        <p:txBody>
-          <a:bodyPr anchorCtr="0" anchor="ctr" bIns="91425" lIns="91425" spcFirstLastPara="1" rIns="91425" wrap="square" tIns="91425">
-            <a:noAutofit/>
-          </a:bodyPr>
-          <a:lstStyle/>
-          <a:p>
-            <a:pPr indent="0" lvl="0" marL="0" marR="0" rtl="0" algn="l">
-              <a:lnSpc>
-                <a:spcPct val="100000"/>
-              </a:lnSpc>
-              <a:spcBef>
-                <a:spcPts val="0"/>
-              </a:spcBef>
-              <a:spcAft>
-                <a:spcPts val="0"/>
-              </a:spcAft>
-              <a:buClr>
-                <a:srgbClr val="000000"/>
-              </a:buClr>
-              <a:buSzPts val="1400"/>
-              <a:buFont typeface="Arial"/>
-              <a:buNone/>
-            </a:pPr>
-            <a:r>
-              <a:t/>
-            </a:r>
-            <a:endParaRPr i="0" sz="1400" u="none" cap="none" strike="noStrike">
-              <a:solidFill>
-                <a:srgbClr val="000000"/>
-              </a:solidFill>
-              <a:latin typeface="Helvetica Neue"/>
-              <a:ea typeface="Helvetica Neue"/>
-              <a:cs typeface="Helvetica Neue"/>
-              <a:sym typeface="Helvetica Neue"/>
-            </a:endParaRPr>
-          </a:p>
-        </p:txBody>
-      </p:sp>
       <p:pic>
         <p:nvPicPr>
           <p:cNvPr descr="preencoded.png" id="58" name="Google Shape;58;p3"/>
@@ -15077,8 +14841,8 @@
           <p:nvPr/>
         </p:nvGraphicFramePr>
         <p:xfrm>
-          <a:off x="548640" y="1417320"/>
-          <a:ext cx="11091672" cy="3236976"/>
+          <a:off x="548640" y="1371600"/>
+          <a:ext cx="11091672" cy="3566160"/>
         </p:xfrm>
         <a:graphic>
           <a:graphicData uri="http://schemas.openxmlformats.org/drawingml/2006/table">
@@ -15087,10 +14851,10 @@
                 <a:tableStyleId>{5C22544A-7EE6-4342-B048-85BDC9FD1C3A}</a:tableStyleId>
               </a:tblPr>
               <a:tblGrid>
-                <a:gridCol w="1920240"/>
-                <a:gridCol w="777240"/>
+                <a:gridCol w="1783080"/>
+                <a:gridCol w="731520"/>
                 <a:gridCol w="4069080"/>
-                <a:gridCol w="4325112"/>
+                <a:gridCol w="4507992"/>
               </a:tblGrid>
               <a:tr h="384048">
                 <a:tc>
@@ -15182,7 +14946,7 @@
                   </a:tcPr>
                 </a:tc>
               </a:tr>
-              <a:tr h="713232">
+              <a:tr h="795528">
                 <a:tc>
                   <a:txBody>
                     <a:bodyPr/>
@@ -15233,13 +14997,24 @@
                     <a:lstStyle/>
                     <a:p>
                       <a:r>
-                        <a:rPr sz="1100" b="0">
+                        <a:rPr sz="1050" b="1">
                           <a:solidFill>
-                            <a:srgbClr val="3D3D3A"/>
+                            <a:srgbClr val="141414"/>
+                          </a:solidFill>
+                          <a:latin typeface="Courier New"/>
+                        </a:rPr>
+                        <a:t>Utilization = usage ÷ license size</a:t>
+                      </a:r>
+                    </a:p>
+                    <a:p>
+                      <a:r>
+                        <a:rPr sz="950">
+                          <a:solidFill>
+                            <a:srgbClr val="706B69"/>
                           </a:solidFill>
                           <a:latin typeface="Arial"/>
                         </a:rPr>
-                        <a:t>consumed ÷ licensed, per customer × product × month; overlapping mid-year contracts are summed before the ratio</a:t>
+                        <a:t>measured each month, per customer and product; a mid-year expansion adds both contracts to the license size</a:t>
                       </a:r>
                     </a:p>
                   </a:txBody>
@@ -15255,13 +15030,13 @@
                     <a:lstStyle/>
                     <a:p>
                       <a:r>
-                        <a:rPr sz="1100" b="0">
+                        <a:rPr sz="1050">
                           <a:solidFill>
                             <a:srgbClr val="3D3D3A"/>
                           </a:solidFill>
                           <a:latin typeface="Arial"/>
                         </a:rPr>
-                        <a:t>&lt; 0.1 → ~0% (shelfware) · rises toward 100% near full use · capped at 80% when above 1.2× (overage flag)</a:t>
+                        <a:t>below 10% of license → 0% (shelfware) · 10–60% → scores 30–90% · 60–100% → scores 90–100% · 100–120% → 100% (healthy peak) · above 120% → capped at 80% (overage)</a:t>
                       </a:r>
                     </a:p>
                   </a:txBody>
@@ -15272,7 +15047,7 @@
                   </a:tcPr>
                 </a:tc>
               </a:tr>
-              <a:tr h="713232">
+              <a:tr h="795528">
                 <a:tc>
                   <a:txBody>
                     <a:bodyPr/>
@@ -15323,13 +15098,24 @@
                     <a:lstStyle/>
                     <a:p>
                       <a:r>
-                        <a:rPr sz="1100" b="0">
+                        <a:rPr sz="1050" b="1">
                           <a:solidFill>
-                            <a:srgbClr val="3D3D3A"/>
+                            <a:srgbClr val="141414"/>
+                          </a:solidFill>
+                          <a:latin typeface="Courier New"/>
+                        </a:rPr>
+                        <a:t>Score = average of all feature grades</a:t>
+                      </a:r>
+                    </a:p>
+                    <a:p>
+                      <a:r>
+                        <a:rPr sz="950">
+                          <a:solidFill>
+                            <a:srgbClr val="706B69"/>
                           </a:solidFill>
                           <a:latin typeface="Arial"/>
                         </a:rPr>
-                        <a:t>average adoption depth across all entitled features; un-adopted features count as 0</a:t>
+                        <a:t>every owned feature is graded monthly on how much it is used</a:t>
                       </a:r>
                     </a:p>
                   </a:txBody>
@@ -15345,13 +15131,13 @@
                     <a:lstStyle/>
                     <a:p>
                       <a:r>
-                        <a:rPr sz="1100" b="0">
+                        <a:rPr sz="1050">
                           <a:solidFill>
                             <a:srgbClr val="3D3D3A"/>
                           </a:solidFill>
                           <a:latin typeface="Arial"/>
                         </a:rPr>
-                        <a:t>per feature vs expected volume: not enabled 0% · idle (&lt;20%) 30% · active (20–80%) 70% · deep (80%+) 100%</a:t>
+                        <a:t>feature grades: not used → 0% · barely used → 30% · used regularly → 70% · used heavily → 100% (own 4 features, really use 1 → 25%)</a:t>
                       </a:r>
                     </a:p>
                   </a:txBody>
@@ -15362,7 +15148,7 @@
                   </a:tcPr>
                 </a:tc>
               </a:tr>
-              <a:tr h="713232">
+              <a:tr h="795528">
                 <a:tc>
                   <a:txBody>
                     <a:bodyPr/>
@@ -15413,13 +15199,24 @@
                     <a:lstStyle/>
                     <a:p>
                       <a:r>
-                        <a:rPr sz="1100" b="0">
+                        <a:rPr sz="1050" b="1">
                           <a:solidFill>
-                            <a:srgbClr val="3D3D3A"/>
+                            <a:srgbClr val="141414"/>
+                          </a:solidFill>
+                          <a:latin typeface="Courier New"/>
+                        </a:rPr>
+                        <a:t>Score = 50% × this month + 30% × last month + 20% × month before</a:t>
+                      </a:r>
+                    </a:p>
+                    <a:p>
+                      <a:r>
+                        <a:rPr sz="950">
+                          <a:solidFill>
+                            <a:srgbClr val="706B69"/>
                           </a:solidFill>
                           <a:latin typeface="Arial"/>
                         </a:rPr>
-                        <a:t>recency-weighted active months over the trailing 3 (50 / 30 / 20)</a:t>
+                        <a:t>each month counts as 1 if the product was meaningfully used (above 10% of license), else 0</a:t>
                       </a:r>
                     </a:p>
                   </a:txBody>
@@ -15435,13 +15232,13 @@
                     <a:lstStyle/>
                     <a:p>
                       <a:r>
-                        <a:rPr sz="1100" b="0">
+                        <a:rPr sz="1050">
                           <a:solidFill>
                             <a:srgbClr val="3D3D3A"/>
                           </a:solidFill>
                           <a:latin typeface="Arial"/>
                         </a:rPr>
-                        <a:t>all 3 months active → 100% · spike-then-drop → 20% · fully inactive → 0%</a:t>
+                        <a:t>used all 3 months → 100% · went quiet this month → 50% · quiet for two months → 20% · not used at all → 0%</a:t>
                       </a:r>
                     </a:p>
                   </a:txBody>
@@ -15452,7 +15249,7 @@
                   </a:tcPr>
                 </a:tc>
               </a:tr>
-              <a:tr h="713232">
+              <a:tr h="795528">
                 <a:tc>
                   <a:txBody>
                     <a:bodyPr/>
@@ -15503,13 +15300,24 @@
                     <a:lstStyle/>
                     <a:p>
                       <a:r>
-                        <a:rPr sz="1100" b="0">
+                        <a:rPr sz="1050" b="1">
                           <a:solidFill>
-                            <a:srgbClr val="3D3D3A"/>
+                            <a:srgbClr val="141414"/>
+                          </a:solidFill>
+                          <a:latin typeface="Courier New"/>
+                        </a:rPr>
+                        <a:t>Score falls from 100% to 0% between day 30 and day 90</a:t>
+                      </a:r>
+                    </a:p>
+                    <a:p>
+                      <a:r>
+                        <a:rPr sz="950">
+                          <a:solidFill>
+                            <a:srgbClr val="706B69"/>
                           </a:solidFill>
                           <a:latin typeface="Arial"/>
                         </a:rPr>
-                        <a:t>days from contract start to first meaningful use (≥ 10% of licensed volume)</a:t>
+                        <a:t>measured from contract start to the first month of real usage (above 10% of license)</a:t>
                       </a:r>
                     </a:p>
                   </a:txBody>
@@ -15525,13 +15333,13 @@
                     <a:lstStyle/>
                     <a:p>
                       <a:r>
-                        <a:rPr sz="1100" b="0">
+                        <a:rPr sz="1050">
                           <a:solidFill>
                             <a:srgbClr val="3D3D3A"/>
                           </a:solidFill>
                           <a:latin typeface="Arial"/>
                         </a:rPr>
-                        <a:t>≤ 30 days → 100% · linear decay to 0% at 90 days · never activated → 0% · first 30 days = grace period</a:t>
+                        <a:t>first real use within 30 days → 100% · slower starts score lower, hitting 0% at 90 days · never used → 0% · no penalty during the first 30 days</a:t>
                       </a:r>
                     </a:p>
                   </a:txBody>
@@ -15548,70 +15356,134 @@
       </p:graphicFrame>
       <p:sp>
         <p:nvSpPr>
-          <p:cNvPr id="64" name="TextBox 63"/>
-          <p:cNvSpPr txBox="1"/>
+          <p:cNvPr id="64" name="Rounded Rectangle 63"/>
+          <p:cNvSpPr/>
           <p:nvPr/>
         </p:nvSpPr>
         <p:spPr>
           <a:xfrm>
-            <a:off x="548640" y="5029200"/>
-            <a:ext cx="11064240" cy="320040"/>
+            <a:off x="548640" y="5257800"/>
+            <a:ext cx="5440680" cy="868680"/>
           </a:xfrm>
-          <a:prstGeom prst="rect">
-            <a:avLst/>
+          <a:prstGeom prst="roundRect">
+            <a:avLst>
+              <a:gd name="adj" fmla="val 8000"/>
+            </a:avLst>
           </a:prstGeom>
-          <a:noFill/>
+          <a:solidFill>
+            <a:srgbClr val="F7F5F2"/>
+          </a:solidFill>
+          <a:ln>
+            <a:noFill/>
+          </a:ln>
+          <a:effectLst/>
         </p:spPr>
+        <p:style>
+          <a:lnRef idx="1">
+            <a:schemeClr val="accent1"/>
+          </a:lnRef>
+          <a:fillRef idx="3">
+            <a:schemeClr val="accent1"/>
+          </a:fillRef>
+          <a:effectRef idx="2">
+            <a:schemeClr val="accent1"/>
+          </a:effectRef>
+          <a:fontRef idx="minor">
+            <a:schemeClr val="lt1"/>
+          </a:fontRef>
+        </p:style>
         <p:txBody>
-          <a:bodyPr wrap="none" lIns="0" rIns="0" tIns="0" bIns="0">
-            <a:spAutoFit/>
-          </a:bodyPr>
+          <a:bodyPr rtlCol="0" anchor="ctr" lIns="128016" rIns="128016" tIns="82296" bIns="82296" wrap="square"/>
           <a:lstStyle/>
           <a:p>
             <a:pPr algn="l"/>
             <a:r>
-              <a:rPr sz="1200" b="1">
+              <a:rPr sz="1150" b="1">
                 <a:solidFill>
                   <a:srgbClr val="141414"/>
                 </a:solidFill>
                 <a:latin typeface="Arial"/>
               </a:rPr>
-              <a:t>VRS = 100 × ( 0.35·Utilization + 0.25·Feature Adoption + 0.25·Sustained Usage + 0.15·Time to Value ) — ARR-weighted roll-ups</a:t>
+              <a:t>Expansion flag</a:t>
+            </a:r>
+          </a:p>
+          <a:p>
+            <a:pPr algn="l"/>
+            <a:r>
+              <a:rPr sz="1050">
+                <a:solidFill>
+                  <a:srgbClr val="3D3D3A"/>
+                </a:solidFill>
+                <a:latin typeface="Arial"/>
+              </a:rPr>
+              <a:t>Using more than 120% of the purchased license, month after month — demand beyond what the customer bought.</a:t>
             </a:r>
           </a:p>
         </p:txBody>
       </p:sp>
       <p:sp>
         <p:nvSpPr>
-          <p:cNvPr id="65" name="TextBox 64"/>
-          <p:cNvSpPr txBox="1"/>
+          <p:cNvPr id="65" name="Rounded Rectangle 64"/>
+          <p:cNvSpPr/>
           <p:nvPr/>
         </p:nvSpPr>
         <p:spPr>
           <a:xfrm>
-            <a:off x="548640" y="5413248"/>
-            <a:ext cx="11064240" cy="320040"/>
+            <a:off x="6199632" y="5257800"/>
+            <a:ext cx="5440680" cy="868680"/>
           </a:xfrm>
-          <a:prstGeom prst="rect">
-            <a:avLst/>
+          <a:prstGeom prst="roundRect">
+            <a:avLst>
+              <a:gd name="adj" fmla="val 8000"/>
+            </a:avLst>
           </a:prstGeom>
-          <a:noFill/>
+          <a:solidFill>
+            <a:srgbClr val="F7F5F2"/>
+          </a:solidFill>
+          <a:ln>
+            <a:noFill/>
+          </a:ln>
+          <a:effectLst/>
         </p:spPr>
+        <p:style>
+          <a:lnRef idx="1">
+            <a:schemeClr val="accent1"/>
+          </a:lnRef>
+          <a:fillRef idx="3">
+            <a:schemeClr val="accent1"/>
+          </a:fillRef>
+          <a:effectRef idx="2">
+            <a:schemeClr val="accent1"/>
+          </a:effectRef>
+          <a:fontRef idx="minor">
+            <a:schemeClr val="lt1"/>
+          </a:fontRef>
+        </p:style>
         <p:txBody>
-          <a:bodyPr wrap="none" lIns="0" rIns="0" tIns="0" bIns="0">
-            <a:spAutoFit/>
-          </a:bodyPr>
+          <a:bodyPr rtlCol="0" anchor="ctr" lIns="128016" rIns="128016" tIns="82296" bIns="82296" wrap="square"/>
           <a:lstStyle/>
           <a:p>
             <a:pPr algn="l"/>
             <a:r>
-              <a:rPr sz="1100" b="0">
-                <a:solidFill>
-                  <a:srgbClr val="706B69"/>
+              <a:rPr sz="1150" b="1">
+                <a:solidFill>
+                  <a:srgbClr val="141414"/>
                 </a:solidFill>
                 <a:latin typeface="Arial"/>
               </a:rPr>
-              <a:t>Guardrail flags: expansion when utilization &gt; 1.2× · single-feature dependency when Feature Adoption &lt; 25% with utilization ≥ 90%</a:t>
+              <a:t>Single-feature dependency flag</a:t>
+            </a:r>
+          </a:p>
+          <a:p>
+            <a:pPr algn="l"/>
+            <a:r>
+              <a:rPr sz="1050">
+                <a:solidFill>
+                  <a:srgbClr val="3D3D3A"/>
+                </a:solidFill>
+                <a:latin typeface="Arial"/>
+              </a:rPr>
+              <a:t>Feature score below 25% while using over 90% of the license — heavy usage that depends on a single feature.</a:t>
             </a:r>
           </a:p>
         </p:txBody>

</xml_diff>